<commit_message>
Fix mobile crash on 3D games; redraw Afterburn craft
- zenith + overdrive: on mobile/low-power, cap pixelRatio to 1.5, drop
  antialias, and SKIP the bloom EffectComposer (render the scene directly) —
  bloom's extra render targets were exhausting mobile GPU memory and crashing
  the tab on tap-to-play. Also swallow webglcontextlost so a lost context
  can't hard-crash. Desktop keeps full bloom.
- afterburn: replace the crude stroke-based starfighter with a solid-fill
  interceptor (metallic dart hull, swept delta wings, red nose, cyan canopy,
  white-hot engine core + plume), scaled up for presence.
- (includes earlier outreach contact/bio updates)

Co-Authored-By: Claude Opus 4.8 <noreply@anthropic.com>
</commit_message>
<xml_diff>
--- a/outreach/programs/Clutch-Studios-Deck.pptx
+++ b/outreach/programs/Clutch-Studios-Deck.pptx
@@ -1906,7 +1906,7 @@
                 <a:ea typeface="Calibri" pitchFamily="34" charset="-122"/>
                 <a:cs typeface="Calibri" pitchFamily="34" charset="-120"/>
               </a:rPr>
-              <a:t>Six live games. Three mechanics. One integration. Playable right now.</a:t>
+              <a:t>Ten live games. Seven mechanics. One integration. Playable right now.</a:t>
             </a:r>
             <a:endParaRPr lang="en-US" sz="1600" dirty="0"/>
           </a:p>
@@ -1998,7 +1998,7 @@
                 <a:ea typeface="Consolas" pitchFamily="34" charset="-122"/>
                 <a:cs typeface="Consolas" pitchFamily="34" charset="-120"/>
               </a:rPr>
-              <a:t>[Founder name] · team@clutchstudios.co</a:t>
+              <a:t>Ali Z · partnership@clutchstudios.co</a:t>
             </a:r>
             <a:endParaRPr lang="en-US" sz="1200" dirty="0"/>
           </a:p>
@@ -2177,7 +2177,7 @@
                 <a:ea typeface="Consolas" pitchFamily="34" charset="-122"/>
                 <a:cs typeface="Consolas" pitchFamily="34" charset="-120"/>
               </a:rPr>
-              <a:t>All six games   </a:t>
+              <a:t>All ten games   </a:t>
             </a:r>
             <a:pPr indent="0" marL="0">
               <a:lnSpc>
@@ -2335,7 +2335,7 @@
                 <a:ea typeface="Trebuchet MS" pitchFamily="34" charset="-122"/>
                 <a:cs typeface="Trebuchet MS" pitchFamily="34" charset="-120"/>
               </a:rPr>
-              <a:t>   ·   [Founder name]   ·   team@clutchstudios.co</a:t>
+              <a:t>   ·   Ali Z   ·   partnership@clutchstudios.co</a:t>
             </a:r>
             <a:endParaRPr lang="en-US" sz="2000" dirty="0"/>
           </a:p>
@@ -2470,7 +2470,7 @@
                 <a:ea typeface="Trebuchet MS" pitchFamily="34" charset="-122"/>
                 <a:cs typeface="Trebuchet MS" pitchFamily="34" charset="-120"/>
               </a:rPr>
-              <a:t>Six live games. </a:t>
+              <a:t>Ten live games. </a:t>
             </a:r>
             <a:pPr indent="0" marL="0">
               <a:lnSpc>
@@ -2487,7 +2487,7 @@
                 <a:ea typeface="Trebuchet MS" pitchFamily="34" charset="-122"/>
                 <a:cs typeface="Trebuchet MS" pitchFamily="34" charset="-120"/>
               </a:rPr>
-              <a:t>Three mechanics. </a:t>
+              <a:t>Seven mechanics. </a:t>
             </a:r>
             <a:pPr indent="0" marL="0">
               <a:lnSpc>
@@ -3413,7 +3413,7 @@
           </p:nvPr>
         </p:nvGraphicFramePr>
         <p:xfrm>
-          <a:off x="640080" y="2011680"/>
+          <a:off x="640080" y="1691640"/>
           <a:ext cx="10881360" cy="914400"/>
         </p:xfrm>
         <a:graphic>
@@ -3421,10 +3421,10 @@
             <a:tbl>
               <a:tblPr/>
               <a:tblGrid>
-                <a:gridCol w="3291840"/>
-                <a:gridCol w="7589520"/>
+                <a:gridCol w="3108960"/>
+                <a:gridCol w="7772400"/>
               </a:tblGrid>
-              <a:tr h="457200">
+              <a:tr h="365760">
                 <a:tc>
                   <a:txBody>
                     <a:bodyPr/>
@@ -3451,7 +3451,7 @@
                       </a:endParaRPr>
                     </a:p>
                   </a:txBody>
-                  <a:tcPr marL="127000" marR="127000" marT="50800" marB="50800" anchor="ctr">
+                  <a:tcPr marL="127000" marR="127000" marT="38100" marB="38100" anchor="ctr">
                     <a:lnL w="12700" cap="flat" cmpd="sng" algn="ctr">
                       <a:solidFill>
                         <a:srgbClr val="2A3142"/>
@@ -3519,7 +3519,7 @@
                       </a:endParaRPr>
                     </a:p>
                   </a:txBody>
-                  <a:tcPr marL="127000" marR="127000" marT="50800" marB="50800" anchor="ctr">
+                  <a:tcPr marL="127000" marR="127000" marT="38100" marB="38100" anchor="ctr">
                     <a:lnL w="12700" cap="flat" cmpd="sng" algn="ctr">
                       <a:solidFill>
                         <a:srgbClr val="2A3142"/>
@@ -3562,7 +3562,7 @@
                   </a:tcPr>
                 </a:tc>
               </a:tr>
-              <a:tr h="777240">
+              <a:tr h="548640">
                 <a:tc>
                   <a:txBody>
                     <a:bodyPr/>
@@ -3572,17 +3572,17 @@
                         <a:buNone/>
                       </a:pPr>
                       <a:r>
-                        <a:rPr lang="en-US" sz="1700" b="1" dirty="0">
+                        <a:rPr lang="en-US" sz="1400" b="1" dirty="0">
                           <a:solidFill>
                             <a:srgbClr val="F4F7FF"/>
                           </a:solidFill>
                         </a:rPr>
-                        <a:t>Crash</a:t>
+                        <a:t>Shared-round climb</a:t>
                       </a:r>
-                      <a:endParaRPr lang="en-US" sz="1700" dirty="0"/>
+                      <a:endParaRPr lang="en-US" sz="1400" dirty="0"/>
                     </a:p>
                   </a:txBody>
-                  <a:tcPr marL="127000" marR="127000" marT="50800" marB="50800" anchor="ctr">
+                  <a:tcPr marL="127000" marR="127000" marT="38100" marB="38100" anchor="ctr">
                     <a:lnL w="12700" cap="flat" cmpd="sng" algn="ctr">
                       <a:solidFill>
                         <a:srgbClr val="2A3142"/>
@@ -3633,17 +3633,17 @@
                         <a:buNone/>
                       </a:pPr>
                       <a:r>
-                        <a:rPr lang="en-US" sz="1600" dirty="0">
+                        <a:rPr lang="en-US" sz="1300" dirty="0">
                           <a:solidFill>
                             <a:srgbClr val="93A0BA"/>
                           </a:solidFill>
                         </a:rPr>
-                        <a:t>Ascent  ·  Overdrive (3D turbo car-crash)</a:t>
+                        <a:t>Zenith  (flagship — one climber, the whole round watches)</a:t>
                       </a:r>
-                      <a:endParaRPr lang="en-US" sz="1600" dirty="0"/>
+                      <a:endParaRPr lang="en-US" sz="1300" dirty="0"/>
                     </a:p>
                   </a:txBody>
-                  <a:tcPr marL="127000" marR="127000" marT="50800" marB="50800" anchor="ctr">
+                  <a:tcPr marL="127000" marR="127000" marT="38100" marB="38100" anchor="ctr">
                     <a:lnL w="12700" cap="flat" cmpd="sng" algn="ctr">
                       <a:solidFill>
                         <a:srgbClr val="2A3142"/>
@@ -3686,7 +3686,7 @@
                   </a:tcPr>
                 </a:tc>
               </a:tr>
-              <a:tr h="777240">
+              <a:tr h="548640">
                 <a:tc>
                   <a:txBody>
                     <a:bodyPr/>
@@ -3696,17 +3696,17 @@
                         <a:buNone/>
                       </a:pPr>
                       <a:r>
-                        <a:rPr lang="en-US" sz="1700" b="1" dirty="0">
+                        <a:rPr lang="en-US" sz="1400" b="1" dirty="0">
                           <a:solidFill>
                             <a:srgbClr val="F4F7FF"/>
                           </a:solidFill>
                         </a:rPr>
-                        <a:t>Step-multiplier climb</a:t>
+                        <a:t>Crash</a:t>
                       </a:r>
-                      <a:endParaRPr lang="en-US" sz="1700" dirty="0"/>
+                      <a:endParaRPr lang="en-US" sz="1400" dirty="0"/>
                     </a:p>
                   </a:txBody>
-                  <a:tcPr marL="127000" marR="127000" marT="50800" marB="50800" anchor="ctr">
+                  <a:tcPr marL="127000" marR="127000" marT="38100" marB="38100" anchor="ctr">
                     <a:lnL w="12700" cap="flat" cmpd="sng" algn="ctr">
                       <a:solidFill>
                         <a:srgbClr val="2A3142"/>
@@ -3757,17 +3757,17 @@
                         <a:buNone/>
                       </a:pPr>
                       <a:r>
-                        <a:rPr lang="en-US" sz="1600" dirty="0">
+                        <a:rPr lang="en-US" sz="1300" dirty="0">
                           <a:solidFill>
                             <a:srgbClr val="93A0BA"/>
                           </a:solidFill>
                         </a:rPr>
-                        <a:t>Zenith  (flagship)  ·  Ascent Cross  ·  Redline</a:t>
+                        <a:t>Ascent  (multiplayer, Moon Pool)  ·  Overdrive (3D turbo car-crash)</a:t>
                       </a:r>
-                      <a:endParaRPr lang="en-US" sz="1600" dirty="0"/>
+                      <a:endParaRPr lang="en-US" sz="1300" dirty="0"/>
                     </a:p>
                   </a:txBody>
-                  <a:tcPr marL="127000" marR="127000" marT="50800" marB="50800" anchor="ctr">
+                  <a:tcPr marL="127000" marR="127000" marT="38100" marB="38100" anchor="ctr">
                     <a:lnL w="12700" cap="flat" cmpd="sng" algn="ctr">
                       <a:solidFill>
                         <a:srgbClr val="2A3142"/>
@@ -3810,7 +3810,7 @@
                   </a:tcPr>
                 </a:tc>
               </a:tr>
-              <a:tr h="777240">
+              <a:tr h="548640">
                 <a:tc>
                   <a:txBody>
                     <a:bodyPr/>
@@ -3820,17 +3820,17 @@
                         <a:buNone/>
                       </a:pPr>
                       <a:r>
-                        <a:rPr lang="en-US" sz="1700" b="1" dirty="0">
+                        <a:rPr lang="en-US" sz="1400" b="1" dirty="0">
                           <a:solidFill>
                             <a:srgbClr val="F4F7FF"/>
                           </a:solidFill>
                         </a:rPr>
-                        <a:t>Mines</a:t>
+                        <a:t>Step-multiplier</a:t>
                       </a:r>
-                      <a:endParaRPr lang="en-US" sz="1700" dirty="0"/>
+                      <a:endParaRPr lang="en-US" sz="1400" dirty="0"/>
                     </a:p>
                   </a:txBody>
-                  <a:tcPr marL="127000" marR="127000" marT="50800" marB="50800" anchor="ctr">
+                  <a:tcPr marL="127000" marR="127000" marT="38100" marB="38100" anchor="ctr">
                     <a:lnL w="12700" cap="flat" cmpd="sng" algn="ctr">
                       <a:solidFill>
                         <a:srgbClr val="2A3142"/>
@@ -3881,17 +3881,513 @@
                         <a:buNone/>
                       </a:pPr>
                       <a:r>
-                        <a:rPr lang="en-US" sz="1600" dirty="0">
+                        <a:rPr lang="en-US" sz="1300" dirty="0">
                           <a:solidFill>
                             <a:srgbClr val="93A0BA"/>
                           </a:solidFill>
                         </a:rPr>
-                        <a:t>Vault  (25-tile, player-set volatility)</a:t>
+                        <a:t>Ascent Cross  (climb platform by platform, one hidden lane)</a:t>
                       </a:r>
-                      <a:endParaRPr lang="en-US" sz="1600" dirty="0"/>
+                      <a:endParaRPr lang="en-US" sz="1300" dirty="0"/>
                     </a:p>
                   </a:txBody>
-                  <a:tcPr marL="127000" marR="127000" marT="50800" marB="50800" anchor="ctr">
+                  <a:tcPr marL="127000" marR="127000" marT="38100" marB="38100" anchor="ctr">
+                    <a:lnL w="12700" cap="flat" cmpd="sng" algn="ctr">
+                      <a:solidFill>
+                        <a:srgbClr val="2A3142"/>
+                      </a:solidFill>
+                      <a:prstDash val="solid"/>
+                      <a:round/>
+                      <a:headEnd type="none" w="med" len="med"/>
+                      <a:tailEnd type="none" w="med" len="med"/>
+                    </a:lnL>
+                    <a:lnR w="12700" cap="flat" cmpd="sng" algn="ctr">
+                      <a:solidFill>
+                        <a:srgbClr val="2A3142"/>
+                      </a:solidFill>
+                      <a:prstDash val="solid"/>
+                      <a:round/>
+                      <a:headEnd type="none" w="med" len="med"/>
+                      <a:tailEnd type="none" w="med" len="med"/>
+                    </a:lnR>
+                    <a:lnT w="12700" cap="flat" cmpd="sng" algn="ctr">
+                      <a:solidFill>
+                        <a:srgbClr val="2A3142"/>
+                      </a:solidFill>
+                      <a:prstDash val="solid"/>
+                      <a:round/>
+                      <a:headEnd type="none" w="med" len="med"/>
+                      <a:tailEnd type="none" w="med" len="med"/>
+                    </a:lnT>
+                    <a:lnB w="12700" cap="flat" cmpd="sng" algn="ctr">
+                      <a:solidFill>
+                        <a:srgbClr val="2A3142"/>
+                      </a:solidFill>
+                      <a:prstDash val="solid"/>
+                      <a:round/>
+                      <a:headEnd type="none" w="med" len="med"/>
+                      <a:tailEnd type="none" w="med" len="med"/>
+                    </a:lnB>
+                    <a:solidFill>
+                      <a:srgbClr val="0D0F17"/>
+                    </a:solidFill>
+                  </a:tcPr>
+                </a:tc>
+              </a:tr>
+              <a:tr h="548640">
+                <a:tc>
+                  <a:txBody>
+                    <a:bodyPr/>
+                    <a:lstStyle/>
+                    <a:p>
+                      <a:pPr indent="0" marL="0">
+                        <a:buNone/>
+                      </a:pPr>
+                      <a:r>
+                        <a:rPr lang="en-US" sz="1400" b="1" dirty="0">
+                          <a:solidFill>
+                            <a:srgbClr val="F4F7FF"/>
+                          </a:solidFill>
+                        </a:rPr>
+                        <a:t>Mines</a:t>
+                      </a:r>
+                      <a:endParaRPr lang="en-US" sz="1400" dirty="0"/>
+                    </a:p>
+                  </a:txBody>
+                  <a:tcPr marL="127000" marR="127000" marT="38100" marB="38100" anchor="ctr">
+                    <a:lnL w="12700" cap="flat" cmpd="sng" algn="ctr">
+                      <a:solidFill>
+                        <a:srgbClr val="2A3142"/>
+                      </a:solidFill>
+                      <a:prstDash val="solid"/>
+                      <a:round/>
+                      <a:headEnd type="none" w="med" len="med"/>
+                      <a:tailEnd type="none" w="med" len="med"/>
+                    </a:lnL>
+                    <a:lnR w="12700" cap="flat" cmpd="sng" algn="ctr">
+                      <a:solidFill>
+                        <a:srgbClr val="2A3142"/>
+                      </a:solidFill>
+                      <a:prstDash val="solid"/>
+                      <a:round/>
+                      <a:headEnd type="none" w="med" len="med"/>
+                      <a:tailEnd type="none" w="med" len="med"/>
+                    </a:lnR>
+                    <a:lnT w="12700" cap="flat" cmpd="sng" algn="ctr">
+                      <a:solidFill>
+                        <a:srgbClr val="2A3142"/>
+                      </a:solidFill>
+                      <a:prstDash val="solid"/>
+                      <a:round/>
+                      <a:headEnd type="none" w="med" len="med"/>
+                      <a:tailEnd type="none" w="med" len="med"/>
+                    </a:lnT>
+                    <a:lnB w="12700" cap="flat" cmpd="sng" algn="ctr">
+                      <a:solidFill>
+                        <a:srgbClr val="2A3142"/>
+                      </a:solidFill>
+                      <a:prstDash val="solid"/>
+                      <a:round/>
+                      <a:headEnd type="none" w="med" len="med"/>
+                      <a:tailEnd type="none" w="med" len="med"/>
+                    </a:lnB>
+                    <a:solidFill>
+                      <a:srgbClr val="0D0F17"/>
+                    </a:solidFill>
+                  </a:tcPr>
+                </a:tc>
+                <a:tc>
+                  <a:txBody>
+                    <a:bodyPr/>
+                    <a:lstStyle/>
+                    <a:p>
+                      <a:pPr indent="0" marL="0">
+                        <a:buNone/>
+                      </a:pPr>
+                      <a:r>
+                        <a:rPr lang="en-US" sz="1300" dirty="0">
+                          <a:solidFill>
+                            <a:srgbClr val="93A0BA"/>
+                          </a:solidFill>
+                        </a:rPr>
+                        <a:t>Vault  (25-tile grid, player-set volatility)</a:t>
+                      </a:r>
+                      <a:endParaRPr lang="en-US" sz="1300" dirty="0"/>
+                    </a:p>
+                  </a:txBody>
+                  <a:tcPr marL="127000" marR="127000" marT="38100" marB="38100" anchor="ctr">
+                    <a:lnL w="12700" cap="flat" cmpd="sng" algn="ctr">
+                      <a:solidFill>
+                        <a:srgbClr val="2A3142"/>
+                      </a:solidFill>
+                      <a:prstDash val="solid"/>
+                      <a:round/>
+                      <a:headEnd type="none" w="med" len="med"/>
+                      <a:tailEnd type="none" w="med" len="med"/>
+                    </a:lnL>
+                    <a:lnR w="12700" cap="flat" cmpd="sng" algn="ctr">
+                      <a:solidFill>
+                        <a:srgbClr val="2A3142"/>
+                      </a:solidFill>
+                      <a:prstDash val="solid"/>
+                      <a:round/>
+                      <a:headEnd type="none" w="med" len="med"/>
+                      <a:tailEnd type="none" w="med" len="med"/>
+                    </a:lnR>
+                    <a:lnT w="12700" cap="flat" cmpd="sng" algn="ctr">
+                      <a:solidFill>
+                        <a:srgbClr val="2A3142"/>
+                      </a:solidFill>
+                      <a:prstDash val="solid"/>
+                      <a:round/>
+                      <a:headEnd type="none" w="med" len="med"/>
+                      <a:tailEnd type="none" w="med" len="med"/>
+                    </a:lnT>
+                    <a:lnB w="12700" cap="flat" cmpd="sng" algn="ctr">
+                      <a:solidFill>
+                        <a:srgbClr val="2A3142"/>
+                      </a:solidFill>
+                      <a:prstDash val="solid"/>
+                      <a:round/>
+                      <a:headEnd type="none" w="med" len="med"/>
+                      <a:tailEnd type="none" w="med" len="med"/>
+                    </a:lnB>
+                    <a:solidFill>
+                      <a:srgbClr val="0D0F17"/>
+                    </a:solidFill>
+                  </a:tcPr>
+                </a:tc>
+              </a:tr>
+              <a:tr h="548640">
+                <a:tc>
+                  <a:txBody>
+                    <a:bodyPr/>
+                    <a:lstStyle/>
+                    <a:p>
+                      <a:pPr indent="0" marL="0">
+                        <a:buNone/>
+                      </a:pPr>
+                      <a:r>
+                        <a:rPr lang="en-US" sz="1400" b="1" dirty="0">
+                          <a:solidFill>
+                            <a:srgbClr val="F4F7FF"/>
+                          </a:solidFill>
+                        </a:rPr>
+                        <a:t>Plinko</a:t>
+                      </a:r>
+                      <a:endParaRPr lang="en-US" sz="1400" dirty="0"/>
+                    </a:p>
+                  </a:txBody>
+                  <a:tcPr marL="127000" marR="127000" marT="38100" marB="38100" anchor="ctr">
+                    <a:lnL w="12700" cap="flat" cmpd="sng" algn="ctr">
+                      <a:solidFill>
+                        <a:srgbClr val="2A3142"/>
+                      </a:solidFill>
+                      <a:prstDash val="solid"/>
+                      <a:round/>
+                      <a:headEnd type="none" w="med" len="med"/>
+                      <a:tailEnd type="none" w="med" len="med"/>
+                    </a:lnL>
+                    <a:lnR w="12700" cap="flat" cmpd="sng" algn="ctr">
+                      <a:solidFill>
+                        <a:srgbClr val="2A3142"/>
+                      </a:solidFill>
+                      <a:prstDash val="solid"/>
+                      <a:round/>
+                      <a:headEnd type="none" w="med" len="med"/>
+                      <a:tailEnd type="none" w="med" len="med"/>
+                    </a:lnR>
+                    <a:lnT w="12700" cap="flat" cmpd="sng" algn="ctr">
+                      <a:solidFill>
+                        <a:srgbClr val="2A3142"/>
+                      </a:solidFill>
+                      <a:prstDash val="solid"/>
+                      <a:round/>
+                      <a:headEnd type="none" w="med" len="med"/>
+                      <a:tailEnd type="none" w="med" len="med"/>
+                    </a:lnT>
+                    <a:lnB w="12700" cap="flat" cmpd="sng" algn="ctr">
+                      <a:solidFill>
+                        <a:srgbClr val="2A3142"/>
+                      </a:solidFill>
+                      <a:prstDash val="solid"/>
+                      <a:round/>
+                      <a:headEnd type="none" w="med" len="med"/>
+                      <a:tailEnd type="none" w="med" len="med"/>
+                    </a:lnB>
+                    <a:solidFill>
+                      <a:srgbClr val="0D0F17"/>
+                    </a:solidFill>
+                  </a:tcPr>
+                </a:tc>
+                <a:tc>
+                  <a:txBody>
+                    <a:bodyPr/>
+                    <a:lstStyle/>
+                    <a:p>
+                      <a:pPr indent="0" marL="0">
+                        <a:buNone/>
+                      </a:pPr>
+                      <a:r>
+                        <a:rPr lang="en-US" sz="1300" dirty="0">
+                          <a:solidFill>
+                            <a:srgbClr val="93A0BA"/>
+                          </a:solidFill>
+                        </a:rPr>
+                        <a:t>Prism  (pick your risk &amp; rows, up to 1000×)</a:t>
+                      </a:r>
+                      <a:endParaRPr lang="en-US" sz="1300" dirty="0"/>
+                    </a:p>
+                  </a:txBody>
+                  <a:tcPr marL="127000" marR="127000" marT="38100" marB="38100" anchor="ctr">
+                    <a:lnL w="12700" cap="flat" cmpd="sng" algn="ctr">
+                      <a:solidFill>
+                        <a:srgbClr val="2A3142"/>
+                      </a:solidFill>
+                      <a:prstDash val="solid"/>
+                      <a:round/>
+                      <a:headEnd type="none" w="med" len="med"/>
+                      <a:tailEnd type="none" w="med" len="med"/>
+                    </a:lnL>
+                    <a:lnR w="12700" cap="flat" cmpd="sng" algn="ctr">
+                      <a:solidFill>
+                        <a:srgbClr val="2A3142"/>
+                      </a:solidFill>
+                      <a:prstDash val="solid"/>
+                      <a:round/>
+                      <a:headEnd type="none" w="med" len="med"/>
+                      <a:tailEnd type="none" w="med" len="med"/>
+                    </a:lnR>
+                    <a:lnT w="12700" cap="flat" cmpd="sng" algn="ctr">
+                      <a:solidFill>
+                        <a:srgbClr val="2A3142"/>
+                      </a:solidFill>
+                      <a:prstDash val="solid"/>
+                      <a:round/>
+                      <a:headEnd type="none" w="med" len="med"/>
+                      <a:tailEnd type="none" w="med" len="med"/>
+                    </a:lnT>
+                    <a:lnB w="12700" cap="flat" cmpd="sng" algn="ctr">
+                      <a:solidFill>
+                        <a:srgbClr val="2A3142"/>
+                      </a:solidFill>
+                      <a:prstDash val="solid"/>
+                      <a:round/>
+                      <a:headEnd type="none" w="med" len="med"/>
+                      <a:tailEnd type="none" w="med" len="med"/>
+                    </a:lnB>
+                    <a:solidFill>
+                      <a:srgbClr val="0D0F17"/>
+                    </a:solidFill>
+                  </a:tcPr>
+                </a:tc>
+              </a:tr>
+              <a:tr h="548640">
+                <a:tc>
+                  <a:txBody>
+                    <a:bodyPr/>
+                    <a:lstStyle/>
+                    <a:p>
+                      <a:pPr indent="0" marL="0">
+                        <a:buNone/>
+                      </a:pPr>
+                      <a:r>
+                        <a:rPr lang="en-US" sz="1400" b="1" dirty="0">
+                          <a:solidFill>
+                            <a:srgbClr val="F4F7FF"/>
+                          </a:solidFill>
+                        </a:rPr>
+                        <a:t>Originals</a:t>
+                      </a:r>
+                      <a:endParaRPr lang="en-US" sz="1400" dirty="0"/>
+                    </a:p>
+                  </a:txBody>
+                  <a:tcPr marL="127000" marR="127000" marT="38100" marB="38100" anchor="ctr">
+                    <a:lnL w="12700" cap="flat" cmpd="sng" algn="ctr">
+                      <a:solidFill>
+                        <a:srgbClr val="2A3142"/>
+                      </a:solidFill>
+                      <a:prstDash val="solid"/>
+                      <a:round/>
+                      <a:headEnd type="none" w="med" len="med"/>
+                      <a:tailEnd type="none" w="med" len="med"/>
+                    </a:lnL>
+                    <a:lnR w="12700" cap="flat" cmpd="sng" algn="ctr">
+                      <a:solidFill>
+                        <a:srgbClr val="2A3142"/>
+                      </a:solidFill>
+                      <a:prstDash val="solid"/>
+                      <a:round/>
+                      <a:headEnd type="none" w="med" len="med"/>
+                      <a:tailEnd type="none" w="med" len="med"/>
+                    </a:lnR>
+                    <a:lnT w="12700" cap="flat" cmpd="sng" algn="ctr">
+                      <a:solidFill>
+                        <a:srgbClr val="2A3142"/>
+                      </a:solidFill>
+                      <a:prstDash val="solid"/>
+                      <a:round/>
+                      <a:headEnd type="none" w="med" len="med"/>
+                      <a:tailEnd type="none" w="med" len="med"/>
+                    </a:lnT>
+                    <a:lnB w="12700" cap="flat" cmpd="sng" algn="ctr">
+                      <a:solidFill>
+                        <a:srgbClr val="2A3142"/>
+                      </a:solidFill>
+                      <a:prstDash val="solid"/>
+                      <a:round/>
+                      <a:headEnd type="none" w="med" len="med"/>
+                      <a:tailEnd type="none" w="med" len="med"/>
+                    </a:lnB>
+                    <a:solidFill>
+                      <a:srgbClr val="0D0F17"/>
+                    </a:solidFill>
+                  </a:tcPr>
+                </a:tc>
+                <a:tc>
+                  <a:txBody>
+                    <a:bodyPr/>
+                    <a:lstStyle/>
+                    <a:p>
+                      <a:pPr indent="0" marL="0">
+                        <a:buNone/>
+                      </a:pPr>
+                      <a:r>
+                        <a:rPr lang="en-US" sz="1300" dirty="0">
+                          <a:solidFill>
+                            <a:srgbClr val="93A0BA"/>
+                          </a:solidFill>
+                        </a:rPr>
+                        <a:t>Dice  ·  Limbo  ·  Wheel  (instant one-tap classics)</a:t>
+                      </a:r>
+                      <a:endParaRPr lang="en-US" sz="1300" dirty="0"/>
+                    </a:p>
+                  </a:txBody>
+                  <a:tcPr marL="127000" marR="127000" marT="38100" marB="38100" anchor="ctr">
+                    <a:lnL w="12700" cap="flat" cmpd="sng" algn="ctr">
+                      <a:solidFill>
+                        <a:srgbClr val="2A3142"/>
+                      </a:solidFill>
+                      <a:prstDash val="solid"/>
+                      <a:round/>
+                      <a:headEnd type="none" w="med" len="med"/>
+                      <a:tailEnd type="none" w="med" len="med"/>
+                    </a:lnL>
+                    <a:lnR w="12700" cap="flat" cmpd="sng" algn="ctr">
+                      <a:solidFill>
+                        <a:srgbClr val="2A3142"/>
+                      </a:solidFill>
+                      <a:prstDash val="solid"/>
+                      <a:round/>
+                      <a:headEnd type="none" w="med" len="med"/>
+                      <a:tailEnd type="none" w="med" len="med"/>
+                    </a:lnR>
+                    <a:lnT w="12700" cap="flat" cmpd="sng" algn="ctr">
+                      <a:solidFill>
+                        <a:srgbClr val="2A3142"/>
+                      </a:solidFill>
+                      <a:prstDash val="solid"/>
+                      <a:round/>
+                      <a:headEnd type="none" w="med" len="med"/>
+                      <a:tailEnd type="none" w="med" len="med"/>
+                    </a:lnT>
+                    <a:lnB w="12700" cap="flat" cmpd="sng" algn="ctr">
+                      <a:solidFill>
+                        <a:srgbClr val="2A3142"/>
+                      </a:solidFill>
+                      <a:prstDash val="solid"/>
+                      <a:round/>
+                      <a:headEnd type="none" w="med" len="med"/>
+                      <a:tailEnd type="none" w="med" len="med"/>
+                    </a:lnB>
+                    <a:solidFill>
+                      <a:srgbClr val="0D0F17"/>
+                    </a:solidFill>
+                  </a:tcPr>
+                </a:tc>
+              </a:tr>
+              <a:tr h="548640">
+                <a:tc>
+                  <a:txBody>
+                    <a:bodyPr/>
+                    <a:lstStyle/>
+                    <a:p>
+                      <a:pPr indent="0" marL="0">
+                        <a:buNone/>
+                      </a:pPr>
+                      <a:r>
+                        <a:rPr lang="en-US" sz="1400" b="1" dirty="0">
+                          <a:solidFill>
+                            <a:srgbClr val="F4F7FF"/>
+                          </a:solidFill>
+                        </a:rPr>
+                        <a:t>Slots</a:t>
+                      </a:r>
+                      <a:endParaRPr lang="en-US" sz="1400" dirty="0"/>
+                    </a:p>
+                  </a:txBody>
+                  <a:tcPr marL="127000" marR="127000" marT="38100" marB="38100" anchor="ctr">
+                    <a:lnL w="12700" cap="flat" cmpd="sng" algn="ctr">
+                      <a:solidFill>
+                        <a:srgbClr val="2A3142"/>
+                      </a:solidFill>
+                      <a:prstDash val="solid"/>
+                      <a:round/>
+                      <a:headEnd type="none" w="med" len="med"/>
+                      <a:tailEnd type="none" w="med" len="med"/>
+                    </a:lnL>
+                    <a:lnR w="12700" cap="flat" cmpd="sng" algn="ctr">
+                      <a:solidFill>
+                        <a:srgbClr val="2A3142"/>
+                      </a:solidFill>
+                      <a:prstDash val="solid"/>
+                      <a:round/>
+                      <a:headEnd type="none" w="med" len="med"/>
+                      <a:tailEnd type="none" w="med" len="med"/>
+                    </a:lnR>
+                    <a:lnT w="12700" cap="flat" cmpd="sng" algn="ctr">
+                      <a:solidFill>
+                        <a:srgbClr val="2A3142"/>
+                      </a:solidFill>
+                      <a:prstDash val="solid"/>
+                      <a:round/>
+                      <a:headEnd type="none" w="med" len="med"/>
+                      <a:tailEnd type="none" w="med" len="med"/>
+                    </a:lnT>
+                    <a:lnB w="12700" cap="flat" cmpd="sng" algn="ctr">
+                      <a:solidFill>
+                        <a:srgbClr val="2A3142"/>
+                      </a:solidFill>
+                      <a:prstDash val="solid"/>
+                      <a:round/>
+                      <a:headEnd type="none" w="med" len="med"/>
+                      <a:tailEnd type="none" w="med" len="med"/>
+                    </a:lnB>
+                    <a:solidFill>
+                      <a:srgbClr val="0D0F17"/>
+                    </a:solidFill>
+                  </a:tcPr>
+                </a:tc>
+                <a:tc>
+                  <a:txBody>
+                    <a:bodyPr/>
+                    <a:lstStyle/>
+                    <a:p>
+                      <a:pPr indent="0" marL="0">
+                        <a:buNone/>
+                      </a:pPr>
+                      <a:r>
+                        <a:rPr lang="en-US" sz="1300" dirty="0">
+                          <a:solidFill>
+                            <a:srgbClr val="93A0BA"/>
+                          </a:solidFill>
+                        </a:rPr>
+                        <a:t>Fortune Reels  (3-reel, wilds, jackpot line)</a:t>
+                      </a:r>
+                      <a:endParaRPr lang="en-US" sz="1300" dirty="0"/>
+                    </a:p>
+                  </a:txBody>
+                  <a:tcPr marL="127000" marR="127000" marT="38100" marB="38100" anchor="ctr">
                     <a:lnL w="12700" cap="flat" cmpd="sng" algn="ctr">
                       <a:solidFill>
                         <a:srgbClr val="2A3142"/>
@@ -3946,12 +4442,12 @@
         </p:nvSpPr>
         <p:spPr>
           <a:xfrm>
-            <a:off x="640080" y="5715000"/>
-            <a:ext cx="10881360" cy="685800"/>
+            <a:off x="640080" y="6035040"/>
+            <a:ext cx="10881360" cy="640080"/>
           </a:xfrm>
           <a:prstGeom prst="roundRect">
             <a:avLst>
-              <a:gd name="adj" fmla="val 12000"/>
+              <a:gd name="adj" fmla="val 12857"/>
             </a:avLst>
           </a:prstGeom>
           <a:solidFill>
@@ -3980,7 +4476,7 @@
         </p:nvSpPr>
         <p:spPr>
           <a:xfrm>
-            <a:off x="1005840" y="5870448"/>
+            <a:off x="1005840" y="6172200"/>
             <a:ext cx="10241280" cy="365760"/>
           </a:xfrm>
           <a:prstGeom prst="rect">
@@ -4005,7 +4501,7 @@
                 <a:ea typeface="Calibri" pitchFamily="34" charset="-122"/>
                 <a:cs typeface="Calibri" pitchFamily="34" charset="-120"/>
               </a:rPr>
-              <a:t>One onboarding, three player audiences.  </a:t>
+              <a:t>One onboarding, several player audiences.  </a:t>
             </a:r>
             <a:pPr indent="0" marL="0">
               <a:buNone/>
@@ -5321,7 +5817,7 @@
                 <a:ea typeface="Trebuchet MS" pitchFamily="34" charset="-122"/>
                 <a:cs typeface="Trebuchet MS" pitchFamily="34" charset="-120"/>
               </a:rPr>
-              <a:t>[Founder name] — Founder</a:t>
+              <a:t>Ali Z — Founder</a:t>
             </a:r>
             <a:endParaRPr lang="en-US" sz="2200" dirty="0"/>
           </a:p>
@@ -5363,7 +5859,7 @@
                 <a:ea typeface="Calibri" pitchFamily="34" charset="-122"/>
                 <a:cs typeface="Calibri" pitchFamily="34" charset="-120"/>
               </a:rPr>
-              <a:t>[One honest line about who you are and any real, verifiable background. If you're solo and new, say so plainly — e.g. “Independent founder; designed and built the RGS and all six games.” A true, modest line beats an inflated résumé.]</a:t>
+              <a:t>Independent founder. I designed and built the RGS and all ten games. We're a new studio, and I'd rather say that plainly than inflate a résumé.</a:t>
             </a:r>
             <a:endParaRPr lang="en-US" sz="1700" dirty="0"/>
           </a:p>
@@ -5402,7 +5898,7 @@
                 <a:ea typeface="Consolas" pitchFamily="34" charset="-122"/>
                 <a:cs typeface="Consolas" pitchFamily="34" charset="-120"/>
               </a:rPr>
-              <a:t>Replace this slide's bracketed text before sending. Do not invent a team or credentials.</a:t>
+              <a:t>The product and the fairness math are the credentials — play it, then verify it.</a:t>
             </a:r>
             <a:endParaRPr lang="en-US" sz="1100" dirty="0"/>
           </a:p>
@@ -5655,7 +6151,7 @@
                 <a:ea typeface="Calibri" pitchFamily="34" charset="-122"/>
                 <a:cs typeface="Calibri" pitchFamily="34" charset="-120"/>
               </a:rPr>
-              <a:t>Six live games across three mechanics</a:t>
+              <a:t>Ten live games across seven mechanics</a:t>
             </a:r>
             <a:endParaRPr lang="en-US" sz="1500" dirty="0"/>
           </a:p>
@@ -6326,7 +6822,7 @@
                 <a:ea typeface="Calibri" pitchFamily="34" charset="-122"/>
                 <a:cs typeface="Calibri" pitchFamily="34" charset="-120"/>
               </a:rPr>
-              <a:t>Six games on one integration</a:t>
+              <a:t>Ten games on one integration</a:t>
             </a:r>
             <a:endParaRPr lang="en-US" sz="1500" dirty="0"/>
           </a:p>

</xml_diff>